<commit_message>
Give the PowerPoint template the red title bar and the logos
</commit_message>
<xml_diff>
--- a/reports-src/slides-reference.pptx
+++ b/reports-src/slides-reference.pptx
@@ -714,8 +714,8 @@
         </p:nvSpPr>
         <p:spPr>
           <a:xfrm>
-            <a:off x="457200" y="1500000"/>
-            <a:ext cx="8229600" cy="1100000"/>
+            <a:off x="757200" y="1150000"/>
+            <a:ext cx="7929600" cy="1100000"/>
           </a:xfrm>
         </p:spPr>
         <p:txBody>
@@ -725,7 +725,7 @@
               <a:buNone/>
               <a:defRPr sz="3600" b="1">
                 <a:solidFill>
-                  <a:srgbClr val="111111"/>
+                  <a:srgbClr val="1A1A1A"/>
                 </a:solidFill>
               </a:defRPr>
             </a:lvl1pPr>
@@ -750,8 +750,8 @@
         </p:nvSpPr>
         <p:spPr>
           <a:xfrm>
-            <a:off x="457200" y="2800000"/>
-            <a:ext cx="8229600" cy="600000"/>
+            <a:off x="757200" y="2250000"/>
+            <a:ext cx="7929600" cy="700000"/>
           </a:xfrm>
         </p:spPr>
         <p:txBody>
@@ -761,7 +761,7 @@
               <a:buNone/>
               <a:defRPr sz="2000" b="0">
                 <a:solidFill>
-                  <a:srgbClr val="8B0000"/>
+                  <a:srgbClr val="4A4A4A"/>
                 </a:solidFill>
               </a:defRPr>
             </a:lvl1pPr>
@@ -839,23 +839,95 @@
           </a:p>
         </p:txBody>
       </p:sp>
+      <p:pic>
+        <p:nvPicPr>
+          <p:cNvPr id="910" name="Logo 1" descr="logos/mcgill.png"/>
+          <p:cNvPicPr>
+            <a:picLocks noChangeAspect="1"/>
+          </p:cNvPicPr>
+          <p:nvPr/>
+        </p:nvPicPr>
+        <p:blipFill>
+          <a:blip r:embed="rId2"/>
+          <a:stretch>
+            <a:fillRect/>
+          </a:stretch>
+        </p:blipFill>
+        <p:spPr>
+          <a:xfrm>
+            <a:off x="1974245" y="4173500"/>
+            <a:ext cx="1852500" cy="520000"/>
+          </a:xfrm>
+          <a:prstGeom prst="rect">
+            <a:avLst/>
+          </a:prstGeom>
+        </p:spPr>
+      </p:pic>
+      <p:pic>
+        <p:nvPicPr>
+          <p:cNvPr id="911" name="Logo 2" descr="logos/douglas.png"/>
+          <p:cNvPicPr>
+            <a:picLocks noChangeAspect="1"/>
+          </p:cNvPicPr>
+          <p:nvPr/>
+        </p:nvPicPr>
+        <p:blipFill>
+          <a:blip r:embed="rId3"/>
+          <a:stretch>
+            <a:fillRect/>
+          </a:stretch>
+        </p:blipFill>
+        <p:spPr>
+          <a:xfrm>
+            <a:off x="4346745" y="4173500"/>
+            <a:ext cx="1469565" cy="520000"/>
+          </a:xfrm>
+          <a:prstGeom prst="rect">
+            <a:avLst/>
+          </a:prstGeom>
+        </p:spPr>
+      </p:pic>
+      <p:pic>
+        <p:nvPicPr>
+          <p:cNvPr id="912" name="Logo 3" descr="logos/stopad.png"/>
+          <p:cNvPicPr>
+            <a:picLocks noChangeAspect="1"/>
+          </p:cNvPicPr>
+          <p:nvPr/>
+        </p:nvPicPr>
+        <p:blipFill>
+          <a:blip r:embed="rId4"/>
+          <a:stretch>
+            <a:fillRect/>
+          </a:stretch>
+        </p:blipFill>
+        <p:spPr>
+          <a:xfrm>
+            <a:off x="6336310" y="4173500"/>
+            <a:ext cx="833444" cy="520000"/>
+          </a:xfrm>
+          <a:prstGeom prst="rect">
+            <a:avLst/>
+          </a:prstGeom>
+        </p:spPr>
+      </p:pic>
       <p:cxnSp>
         <p:nvCxnSpPr>
-          <p:cNvPr id="900" name="Title rule"/>
+          <p:cNvPr id="900" name="Title bar"/>
           <p:cNvCxnSpPr/>
           <p:nvPr userDrawn="1"/>
         </p:nvCxnSpPr>
         <p:spPr>
           <a:xfrm>
-            <a:off x="457200" y="2700000"/>
-            <a:ext cx="8229600" cy="0"/>
+            <a:off x="457200" y="1150000"/>
+            <a:ext cx="0" cy="1800000"/>
           </a:xfrm>
           <a:prstGeom prst="line">
             <a:avLst/>
           </a:prstGeom>
-          <a:ln w="25400">
+          <a:ln w="50800">
             <a:solidFill>
-              <a:srgbClr val="8B0000"/>
+              <a:srgbClr val="ED1B2F"/>
             </a:solidFill>
           </a:ln>
         </p:spPr>
@@ -2618,7 +2690,7 @@
               <a:buNone/>
               <a:defRPr sz="2600" b="1">
                 <a:solidFill>
-                  <a:srgbClr val="111111"/>
+                  <a:srgbClr val="1A1A1A"/>
                 </a:solidFill>
               </a:defRPr>
             </a:lvl1pPr>
@@ -3316,27 +3388,6 @@
           </a:p>
         </p:txBody>
       </p:sp>
-      <p:cxnSp>
-        <p:nvCxnSpPr>
-          <p:cNvPr id="900" name="Title rule"/>
-          <p:cNvCxnSpPr/>
-          <p:nvPr userDrawn="1"/>
-        </p:nvCxnSpPr>
-        <p:spPr>
-          <a:xfrm>
-            <a:off x="457200" y="800000"/>
-            <a:ext cx="8229600" cy="0"/>
-          </a:xfrm>
-          <a:prstGeom prst="line">
-            <a:avLst/>
-          </a:prstGeom>
-          <a:ln w="19050">
-            <a:solidFill>
-              <a:srgbClr val="8B0000"/>
-            </a:solidFill>
-          </a:ln>
-        </p:spPr>
-      </p:cxnSp>
     </p:spTree>
     <p:extLst>
       <p:ext uri="{BB962C8B-B14F-4D97-AF65-F5344CB8AC3E}">
@@ -3948,7 +3999,7 @@
         <a:sysClr val="window" lastClr="FFFFFF"/>
       </a:lt1>
       <a:dk2>
-        <a:srgbClr val="111111"/>
+        <a:srgbClr val="1A1A1A"/>
       </a:dk2>
       <a:lt2>
         <a:srgbClr val="F5F5F5"/>
@@ -3957,22 +4008,22 @@
         <a:srgbClr val="404040"/>
       </a:accent1>
       <a:accent2>
-        <a:srgbClr val="8B0000"/>
+        <a:srgbClr val="ED1B2F"/>
       </a:accent2>
       <a:accent3>
-        <a:srgbClr val="191970"/>
+        <a:srgbClr val="1A6C7A"/>
       </a:accent3>
       <a:accent4>
         <a:srgbClr val="4477AA"/>
       </a:accent4>
       <a:accent5>
-        <a:srgbClr val="EE6677"/>
+        <a:srgbClr val="228833"/>
       </a:accent5>
       <a:accent6>
         <a:srgbClr val="997700"/>
       </a:accent6>
       <a:hlink>
-        <a:srgbClr val="8B0000"/>
+        <a:srgbClr val="177DB3"/>
       </a:hlink>
       <a:folHlink>
         <a:srgbClr val="5C5C5C"/>

</xml_diff>